<commit_message>
Add proposal PPTX: Hoyer Law (June 5, 2026) — Run 3 Starter + FCTO L1
3-slide proposal deck reflecting updated package recommendation:
Full Service Marketing Starter ($4,847/mo) + Fractional CTO Level 1
($3,297/mo) = $8,144/mo total, ad spend $5,500–$14,000/mo.

Co-Authored-By: Claude Sonnet 4.6 <noreply@anthropic.com>
</commit_message>
<xml_diff>
--- a/hoyer-law/Hoyer_Law_June_5_2026_Proposal.pptx
+++ b/hoyer-law/Hoyer_Law_June_5_2026_Proposal.pptx
@@ -3508,7 +3508,7 @@
                 </a:solidFill>
                 <a:latin typeface="Calibri"/>
               </a:rPr>
-              <a:t>CRITICAL</a:t>
+              <a:t>NO PAID ADS</a:t>
             </a:r>
           </a:p>
         </p:txBody>
@@ -3541,7 +3541,7 @@
                 </a:solidFill>
                 <a:latin typeface="Calibri"/>
               </a:rPr>
-              <a:t>No paid ads active</a:t>
+              <a:t>No paid channels</a:t>
             </a:r>
           </a:p>
         </p:txBody>
@@ -3697,7 +3697,7 @@
                 </a:solidFill>
                 <a:latin typeface="Calibri"/>
               </a:rPr>
-              <a:t>AMBER</a:t>
+              <a:t>GAPS EXIST</a:t>
             </a:r>
           </a:p>
         </p:txBody>
@@ -3730,7 +3730,7 @@
                 </a:solidFill>
                 <a:latin typeface="Calibri"/>
               </a:rPr>
-              <a:t>Delegation in place</a:t>
+              <a:t>No confirmed SOP</a:t>
             </a:r>
           </a:p>
         </p:txBody>
@@ -3886,7 +3886,7 @@
                 </a:solidFill>
                 <a:latin typeface="Calibri"/>
               </a:rPr>
-              <a:t>AMBER</a:t>
+              <a:t>NEEDS STRUCTURE</a:t>
             </a:r>
           </a:p>
         </p:txBody>
@@ -3919,7 +3919,7 @@
                 </a:solidFill>
                 <a:latin typeface="Calibri"/>
               </a:rPr>
-              <a:t>GM role not formal</a:t>
+              <a:t>GM not formalized</a:t>
             </a:r>
           </a:p>
         </p:txBody>
@@ -4075,7 +4075,7 @@
                 </a:solidFill>
                 <a:latin typeface="Calibri"/>
               </a:rPr>
-              <a:t>AMBER</a:t>
+              <a:t>NO VISIBILITY</a:t>
             </a:r>
           </a:p>
         </p:txBody>
@@ -4108,7 +4108,7 @@
                 </a:solidFill>
                 <a:latin typeface="Calibri"/>
               </a:rPr>
-              <a:t>No margin visibility</a:t>
+              <a:t>No profit tracking</a:t>
             </a:r>
           </a:p>
         </p:txBody>
@@ -4297,7 +4297,7 @@
                 </a:solidFill>
                 <a:latin typeface="Calibri"/>
               </a:rPr>
-              <a:t>No paid ads — CoilLaw captures every paid click in Utah County</a:t>
+              <a:t>No paid ads — CoilLaw &amp; Arnold Wadsworth capture every high-intent search click</a:t>
             </a:r>
           </a:p>
         </p:txBody>
@@ -4453,7 +4453,7 @@
                 </a:solidFill>
                 <a:latin typeface="Calibri"/>
               </a:rPr>
-              <a:t>CoilLaw: 308 reviews vs. 139 — 3-pack visibility gap widens monthly</a:t>
+              <a:t>CoilLaw: 308 reviews at 4.8 vs. Hoyer Law's 139 — 3-pack visibility suppressed</a:t>
             </a:r>
           </a:p>
         </p:txBody>
@@ -4609,7 +4609,7 @@
                 </a:solidFill>
                 <a:latin typeface="Calibri"/>
               </a:rPr>
-              <a:t>NAP errors on YellowPages suppress rankings already earned</a:t>
+              <a:t>Three phone numbers &amp; outdated address confirmed across directories — SEO liability</a:t>
             </a:r>
           </a:p>
         </p:txBody>
@@ -4765,7 +4765,7 @@
                 </a:solidFill>
                 <a:latin typeface="Calibri"/>
               </a:rPr>
-              <a:t>139 reviews + bilingual staff = unique advantage no competitor holds</a:t>
+              <a:t>10-person bilingual team + GM already in place — self-managing foundation exists</a:t>
             </a:r>
           </a:p>
         </p:txBody>
@@ -5143,7 +5143,7 @@
                 </a:solidFill>
                 <a:latin typeface="Calibri"/>
               </a:rPr>
-              <a:t>4.8★ · multi-location Utah County</a:t>
+              <a:t>4.8★ · multi-location · paying ads</a:t>
             </a:r>
           </a:p>
         </p:txBody>
@@ -5221,7 +5221,7 @@
                 </a:solidFill>
                 <a:latin typeface="Calibri"/>
               </a:rPr>
-              <a:t>Arnold, Wadsworth &amp; Coggins</a:t>
+              <a:t>Arnold Wadsworth &amp; Coggins</a:t>
             </a:r>
           </a:p>
         </p:txBody>
@@ -5254,7 +5254,7 @@
                 </a:solidFill>
                 <a:latin typeface="Calibri"/>
               </a:rPr>
-              <a:t>Unverified</a:t>
+              <a:t>unverified</a:t>
             </a:r>
           </a:p>
         </p:txBody>
@@ -5287,7 +5287,7 @@
                 </a:solidFill>
                 <a:latin typeface="Calibri"/>
               </a:rPr>
-              <a:t>Lehi office · national award recognition</a:t>
+              <a:t>Lehi office · multi-attorney · paid</a:t>
             </a:r>
           </a:p>
         </p:txBody>
@@ -5365,7 +5365,7 @@
                 </a:solidFill>
                 <a:latin typeface="Calibri"/>
               </a:rPr>
-              <a:t>SeegLawUtah — H. Seegmiller</a:t>
+              <a:t>SeegLawUtah</a:t>
             </a:r>
           </a:p>
         </p:txBody>
@@ -5398,7 +5398,7 @@
                 </a:solidFill>
                 <a:latin typeface="Calibri"/>
               </a:rPr>
-              <a:t>20+ yrs exp</a:t>
+              <a:t>unverified</a:t>
             </a:r>
           </a:p>
         </p:txBody>
@@ -5431,7 +5431,7 @@
                 </a:solidFill>
                 <a:latin typeface="Calibri"/>
               </a:rPr>
-              <a:t>Exclusive family law · same geography</a:t>
+              <a:t>family law only · 20+ yrs · local</a:t>
             </a:r>
           </a:p>
         </p:txBody>
@@ -5884,7 +5884,7 @@
                 </a:solidFill>
                 <a:latin typeface="Calibri"/>
               </a:rPr>
-              <a:t>Your Growth Plan: 3 Priorities to Reach $8M Revenue</a:t>
+              <a:t>Your Growth Plan: 3 Priorities to Reach $1.2M Revenue</a:t>
             </a:r>
           </a:p>
         </p:txBody>
@@ -6040,7 +6040,7 @@
                 </a:solidFill>
                 <a:latin typeface="Calibri"/>
               </a:rPr>
-              <a:t>Lead Generation, Intake, Team, and Profit Plan — all four must work together. Missing any one means growth stalls regardless of effort. When all four work, Casey can step away from operations and trust the firm delivers — every single month.</a:t>
+              <a:t>Marketing, Intake, Team, and Profit must all work together. Missing any one means growth stalls regardless of ad spend. When all four pillars fire, Casey can step away from the day-to-day and trust the firm handles itself.</a:t>
             </a:r>
           </a:p>
         </p:txBody>
@@ -6118,7 +6118,7 @@
                 </a:solidFill>
                 <a:latin typeface="Calibri"/>
               </a:rPr>
-              <a:t>$4M → $8M Revenue</a:t>
+              <a:t>~$600K → $1.2M revenue</a:t>
             </a:r>
           </a:p>
         </p:txBody>
@@ -6151,7 +6151,7 @@
                 </a:solidFill>
                 <a:latin typeface="Calibri"/>
               </a:rPr>
-              <a:t>Step back and trust the firm runs</a:t>
+              <a:t>Step away — and trust the firm runs</a:t>
             </a:r>
           </a:p>
         </p:txBody>
@@ -6418,7 +6418,7 @@
                 </a:solidFill>
                 <a:latin typeface="Calibri"/>
               </a:rPr>
-              <a:t>Launch Google Ads for divorce + custody in Utah County</a:t>
+              <a:t>Turn Google into a daily family law pipeline</a:t>
             </a:r>
           </a:p>
         </p:txBody>
@@ -6541,7 +6541,7 @@
                 </a:solidFill>
                 <a:latin typeface="Calibri"/>
               </a:rPr>
-              <a:t>Activate LSA — get Google Screened on 139 reviews</a:t>
+              <a:t>Launch LSA — get Google Screened today</a:t>
             </a:r>
           </a:p>
         </p:txBody>
@@ -6664,7 +6664,7 @@
                 </a:solidFill>
                 <a:latin typeface="Calibri"/>
               </a:rPr>
-              <a:t>Run Spanish-language ads — no local competitor doing it</a:t>
+              <a:t>Spanish-language ads — own an unserved segment</a:t>
             </a:r>
           </a:p>
         </p:txBody>
@@ -6787,7 +6787,7 @@
                 </a:solidFill>
                 <a:latin typeface="Calibri"/>
               </a:rPr>
-              <a:t>Fix NAP errors to recover suppressed 3-pack rankings</a:t>
+              <a:t>Fix NAP data and restore your ranking potential</a:t>
             </a:r>
           </a:p>
         </p:txBody>
@@ -6910,7 +6910,7 @@
                 </a:solidFill>
                 <a:latin typeface="Calibri"/>
               </a:rPr>
-              <a:t>Turn Google into a client pipeline that runs itself</a:t>
+              <a:t>Compete for paid placements CoilLaw is winning</a:t>
             </a:r>
           </a:p>
         </p:txBody>
@@ -7177,7 +7177,7 @@
                 </a:solidFill>
                 <a:latin typeface="Calibri"/>
               </a:rPr>
-              <a:t>Build after-hours response — stop losing evening leads</a:t>
+              <a:t>Capture leads that arrive after hours and weekends</a:t>
             </a:r>
           </a:p>
         </p:txBody>
@@ -7300,7 +7300,7 @@
                 </a:solidFill>
                 <a:latin typeface="Calibri"/>
               </a:rPr>
-              <a:t>Define intake SOP with a 1-hour response standard</a:t>
+              <a:t>Build intake SOP so every call converts consistently</a:t>
             </a:r>
           </a:p>
         </p:txBody>
@@ -7423,7 +7423,7 @@
                 </a:solidFill>
                 <a:latin typeface="Calibri"/>
               </a:rPr>
-              <a:t>Automate consultation booking from website forms</a:t>
+              <a:t>Set a 1-hour response standard for all leads</a:t>
             </a:r>
           </a:p>
         </p:txBody>
@@ -7546,7 +7546,7 @@
                 </a:solidFill>
                 <a:latin typeface="Calibri"/>
               </a:rPr>
-              <a:t>Track consultation-to-retainer conversion rate</a:t>
+              <a:t>Train staff on a proven family law consult script</a:t>
             </a:r>
           </a:p>
         </p:txBody>
@@ -7669,7 +7669,7 @@
                 </a:solidFill>
                 <a:latin typeface="Calibri"/>
               </a:rPr>
-              <a:t>Fix intake so every lead becomes a booked consult</a:t>
+              <a:t>Track lead-to-consult rate every month</a:t>
             </a:r>
           </a:p>
         </p:txBody>
@@ -7936,7 +7936,7 @@
                 </a:solidFill>
                 <a:latin typeface="Calibri"/>
               </a:rPr>
-              <a:t>Formalize Analia's GM authority + team KPI dashboard</a:t>
+              <a:t>Formalize Analia's GM authority and decision rights</a:t>
             </a:r>
           </a:p>
         </p:txBody>
@@ -8059,7 +8059,7 @@
                 </a:solidFill>
                 <a:latin typeface="Calibri"/>
               </a:rPr>
-              <a:t>Weekly accountability meeting structure for all roles</a:t>
+              <a:t>Launch weekly KPI dashboard and accountability meeting</a:t>
             </a:r>
           </a:p>
         </p:txBody>
@@ -8182,7 +8182,7 @@
                 </a:solidFill>
                 <a:latin typeface="Calibri"/>
               </a:rPr>
-              <a:t>Build case-type profitability tracking monthly</a:t>
+              <a:t>Deploy AI intake response — handle leads after hours</a:t>
             </a:r>
           </a:p>
         </p:txBody>
@@ -8305,7 +8305,7 @@
                 </a:solidFill>
                 <a:latin typeface="Calibri"/>
               </a:rPr>
-              <a:t>Build owner comp plan — know what you take home</a:t>
+              <a:t>Track profitability by case type — know your margins</a:t>
             </a:r>
           </a:p>
         </p:txBody>
@@ -8428,7 +8428,7 @@
                 </a:solidFill>
                 <a:latin typeface="Calibri"/>
               </a:rPr>
-              <a:t>Two-location protocol so Casey can genuinely step back</a:t>
+              <a:t>Build monthly dashboard: revenue, costs, take-home</a:t>
             </a:r>
           </a:p>
         </p:txBody>
@@ -8815,7 +8815,7 @@
                 </a:solidFill>
                 <a:latin typeface="Calibri"/>
               </a:rPr>
-              <a:t>FULL SERVICE MARKETING — GROWTH</a:t>
+              <a:t>FULL SERVICE MARKETING — STARTER</a:t>
             </a:r>
           </a:p>
         </p:txBody>
@@ -8848,7 +8848,7 @@
                 </a:solidFill>
                 <a:latin typeface="Calibri"/>
               </a:rPr>
-              <a:t>$7,397</a:t>
+              <a:t>$4,847</a:t>
             </a:r>
           </a:p>
         </p:txBody>
@@ -8914,7 +8914,7 @@
                 </a:solidFill>
                 <a:latin typeface="Calibri"/>
               </a:rPr>
-              <a:t>$8,997/mo</a:t>
+              <a:t>$5,697/mo</a:t>
             </a:r>
           </a:p>
         </p:txBody>
@@ -8992,7 +8992,7 @@
                 </a:solidFill>
                 <a:latin typeface="Calibri"/>
               </a:rPr>
-              <a:t>Google · LSA · Meta · Spanish campaigns · SEO · GBP</a:t>
+              <a:t>Google Ads · LSA · Meta · SEO · Spanish-language campaigns</a:t>
             </a:r>
           </a:p>
         </p:txBody>
@@ -9115,7 +9115,7 @@
                 </a:solidFill>
                 <a:latin typeface="Calibri"/>
               </a:rPr>
-              <a:t>MASTER'S CIRCLE</a:t>
+              <a:t>FRACTIONAL CTO LEVEL 1</a:t>
             </a:r>
           </a:p>
         </p:txBody>
@@ -9148,7 +9148,7 @@
                 </a:solidFill>
                 <a:latin typeface="Calibri"/>
               </a:rPr>
-              <a:t>$4,600</a:t>
+              <a:t>$3,297</a:t>
             </a:r>
           </a:p>
         </p:txBody>
@@ -9214,7 +9214,7 @@
                 </a:solidFill>
                 <a:latin typeface="Calibri"/>
               </a:rPr>
-              <a:t>$4,997/mo</a:t>
+              <a:t>$3,797/mo</a:t>
             </a:r>
           </a:p>
         </p:txBody>
@@ -9292,7 +9292,7 @@
                 </a:solidFill>
                 <a:latin typeface="Calibri"/>
               </a:rPr>
-              <a:t>Weekly coaching · masterminds · GM framework · profit plan</a:t>
+              <a:t>Claude Enterprise · AI Skills · CTO-led rollout · staff training</a:t>
             </a:r>
           </a:p>
         </p:txBody>
@@ -9403,7 +9403,7 @@
                 </a:solidFill>
                 <a:latin typeface="Calibri"/>
               </a:rPr>
-              <a:t>$11,997 / mo</a:t>
+              <a:t>$8,144 / mo</a:t>
             </a:r>
           </a:p>
         </p:txBody>
@@ -9436,7 +9436,7 @@
                 </a:solidFill>
                 <a:latin typeface="Calibri"/>
               </a:rPr>
-              <a:t>Save $1,997/mo by bundling</a:t>
+              <a:t>Save $1,350/mo by bundling</a:t>
             </a:r>
           </a:p>
         </p:txBody>
@@ -9514,7 +9514,7 @@
                 </a:solidFill>
                 <a:latin typeface="Calibri"/>
               </a:rPr>
-              <a:t>+ Recommended ad spend: $10,000–$45,000/mo paid directly to Google/Meta</a:t>
+              <a:t>+ Recommended ad spend: $5,500–$14,000/mo paid directly to Google/Meta/LSA</a:t>
             </a:r>
           </a:p>
         </p:txBody>
@@ -9658,7 +9658,7 @@
                 </a:solidFill>
                 <a:latin typeface="Calibri"/>
               </a:rPr>
-              <a:t>~$10,000</a:t>
+              <a:t>~$10,000 (default)</a:t>
             </a:r>
           </a:p>
         </p:txBody>
@@ -9736,7 +9736,7 @@
                 </a:solidFill>
                 <a:latin typeface="Calibri"/>
               </a:rPr>
-              <a:t>Conservative  (~15 cases/mo):</a:t>
+              <a:t>Conservative  (~8 cases/mo):</a:t>
             </a:r>
           </a:p>
         </p:txBody>
@@ -9769,7 +9769,7 @@
                 </a:solidFill>
                 <a:latin typeface="Calibri"/>
               </a:rPr>
-              <a:t>~$150,000 revenue · ~15× ROAS</a:t>
+              <a:t>~$80,000 revenue · ~15× ROAS</a:t>
             </a:r>
           </a:p>
         </p:txBody>
@@ -9802,7 +9802,7 @@
                 </a:solidFill>
                 <a:latin typeface="Calibri"/>
               </a:rPr>
-              <a:t>Aggressive  (~79 cases/mo):</a:t>
+              <a:t>Aggressive  (~25 cases/mo):</a:t>
             </a:r>
           </a:p>
         </p:txBody>
@@ -9835,7 +9835,7 @@
                 </a:solidFill>
                 <a:latin typeface="Calibri"/>
               </a:rPr>
-              <a:t>~$790,000 revenue · ~18× ROAS</a:t>
+              <a:t>~$250,000 revenue · ~18× ROAS</a:t>
             </a:r>
           </a:p>
         </p:txBody>
@@ -9979,7 +9979,7 @@
                 </a:solidFill>
                 <a:latin typeface="Calibri"/>
               </a:rPr>
-              <a:t>Launch Google, LSA, Meta, and Spanish campaigns</a:t>
+              <a:t>Launch Google Ads, LSA, Meta — family law + Spanish</a:t>
             </a:r>
           </a:p>
         </p:txBody>
@@ -10090,7 +10090,7 @@
                 </a:solidFill>
                 <a:latin typeface="Calibri"/>
               </a:rPr>
-              <a:t>Correct all NAP errors across directories</a:t>
+              <a:t>Fix NAP inconsistencies across all directories</a:t>
             </a:r>
           </a:p>
         </p:txBody>
@@ -10201,7 +10201,7 @@
                 </a:solidFill>
                 <a:latin typeface="Calibri"/>
               </a:rPr>
-              <a:t>Activate website lead response + booking system</a:t>
+              <a:t>Fractional CTO kickoff — Claude Enterprise + AI Skills</a:t>
             </a:r>
           </a:p>
         </p:txBody>
@@ -10312,7 +10312,7 @@
                 </a:solidFill>
                 <a:latin typeface="Calibri"/>
               </a:rPr>
-              <a:t>GM coaching kickoff — Analia's framework built</a:t>
+              <a:t>Website lead response system + intake dashboard live</a:t>
             </a:r>
           </a:p>
         </p:txBody>
@@ -10423,7 +10423,7 @@
                 </a:solidFill>
                 <a:latin typeface="Calibri"/>
               </a:rPr>
-              <a:t>Financial dashboard + case profitability live</a:t>
+              <a:t>GM framework, KPI dashboard, and AI fully operational</a:t>
             </a:r>
           </a:p>
         </p:txBody>
@@ -10501,7 +10501,7 @@
                 </a:solidFill>
                 <a:latin typeface="Calibri"/>
               </a:rPr>
-              <a:t>"You have spent 15 years building this firm. Now it is time to build it so it works without you."</a:t>
+              <a:t>“The reputation is here. The team is here. The bilingual staff to serve all of Utah County is here. The only thing missing is the growth engine — and that is exactly what we are building next.”</a:t>
             </a:r>
           </a:p>
         </p:txBody>

</xml_diff>

<commit_message>
Add proposal PPTX: Hoyer Law (June 5, 2026)
Updated for Run 4: intake and team pillars corrected to GREEN,
CoilLaw review count updated to 369, Priority 2 reframed as
Amplify Intake & Grow Conversions per sales rep notes.

Co-Authored-By: Claude Sonnet 4.6 <noreply@anthropic.com>
</commit_message>
<xml_diff>
--- a/hoyer-law/Hoyer_Law_June_5_2026_Proposal.pptx
+++ b/hoyer-law/Hoyer_Law_June_5_2026_Proposal.pptx
@@ -3508,7 +3508,7 @@
                 </a:solidFill>
                 <a:latin typeface="Calibri"/>
               </a:rPr>
-              <a:t>NO PAID ADS</a:t>
+              <a:t>CRITICAL</a:t>
             </a:r>
           </a:p>
         </p:txBody>
@@ -3541,7 +3541,7 @@
                 </a:solidFill>
                 <a:latin typeface="Calibri"/>
               </a:rPr>
-              <a:t>No paid channels</a:t>
+              <a:t>No paid ads observed</a:t>
             </a:r>
           </a:p>
         </p:txBody>
@@ -3555,6 +3555,384 @@
         <p:spPr>
           <a:xfrm>
             <a:off x="2542032" y="1005840"/>
+            <a:ext cx="804672" cy="164592"/>
+          </a:xfrm>
+          <a:prstGeom prst="rect">
+            <a:avLst/>
+          </a:prstGeom>
+          <a:solidFill>
+            <a:srgbClr val="16A34A"/>
+          </a:solidFill>
+          <a:ln>
+            <a:solidFill>
+              <a:srgbClr val="FFFFFF"/>
+            </a:solidFill>
+          </a:ln>
+        </p:spPr>
+        <p:style>
+          <a:lnRef idx="1">
+            <a:schemeClr val="accent1"/>
+          </a:lnRef>
+          <a:fillRef idx="3">
+            <a:schemeClr val="accent1"/>
+          </a:fillRef>
+          <a:effectRef idx="2">
+            <a:schemeClr val="accent1"/>
+          </a:effectRef>
+          <a:fontRef idx="minor">
+            <a:schemeClr val="lt1"/>
+          </a:fontRef>
+        </p:style>
+        <p:txBody>
+          <a:bodyPr rtlCol="0" anchor="ctr"/>
+          <a:lstStyle/>
+          <a:p>
+            <a:pPr algn="ctr"/>
+          </a:p>
+        </p:txBody>
+      </p:sp>
+      <p:sp>
+        <p:nvSpPr>
+          <p:cNvPr id="15" name="Rectangle 14"/>
+          <p:cNvSpPr/>
+          <p:nvPr/>
+        </p:nvSpPr>
+        <p:spPr>
+          <a:xfrm>
+            <a:off x="2542032" y="1170432"/>
+            <a:ext cx="804672" cy="676656"/>
+          </a:xfrm>
+          <a:prstGeom prst="rect">
+            <a:avLst/>
+          </a:prstGeom>
+          <a:solidFill>
+            <a:srgbClr val="162947"/>
+          </a:solidFill>
+          <a:ln>
+            <a:solidFill>
+              <a:srgbClr val="FFFFFF"/>
+            </a:solidFill>
+          </a:ln>
+        </p:spPr>
+        <p:style>
+          <a:lnRef idx="1">
+            <a:schemeClr val="accent1"/>
+          </a:lnRef>
+          <a:fillRef idx="3">
+            <a:schemeClr val="accent1"/>
+          </a:fillRef>
+          <a:effectRef idx="2">
+            <a:schemeClr val="accent1"/>
+          </a:effectRef>
+          <a:fontRef idx="minor">
+            <a:schemeClr val="lt1"/>
+          </a:fontRef>
+        </p:style>
+        <p:txBody>
+          <a:bodyPr rtlCol="0" anchor="ctr"/>
+          <a:lstStyle/>
+          <a:p>
+            <a:pPr algn="ctr"/>
+          </a:p>
+        </p:txBody>
+      </p:sp>
+      <p:sp>
+        <p:nvSpPr>
+          <p:cNvPr id="16" name="TextBox 15"/>
+          <p:cNvSpPr txBox="1"/>
+          <p:nvPr/>
+        </p:nvSpPr>
+        <p:spPr>
+          <a:xfrm>
+            <a:off x="2596896" y="1188720"/>
+            <a:ext cx="694944" cy="237744"/>
+          </a:xfrm>
+          <a:prstGeom prst="rect">
+            <a:avLst/>
+          </a:prstGeom>
+          <a:noFill/>
+        </p:spPr>
+        <p:txBody>
+          <a:bodyPr wrap="square"/>
+          <a:lstStyle/>
+          <a:p>
+            <a:pPr algn="l"/>
+            <a:r>
+              <a:rPr sz="800" b="1" i="0">
+                <a:solidFill>
+                  <a:srgbClr val="FFFFFF"/>
+                </a:solidFill>
+                <a:latin typeface="Calibri"/>
+              </a:rPr>
+              <a:t>Intake</a:t>
+            </a:r>
+          </a:p>
+        </p:txBody>
+      </p:sp>
+      <p:sp>
+        <p:nvSpPr>
+          <p:cNvPr id="17" name="TextBox 16"/>
+          <p:cNvSpPr txBox="1"/>
+          <p:nvPr/>
+        </p:nvSpPr>
+        <p:spPr>
+          <a:xfrm>
+            <a:off x="2596896" y="1417320"/>
+            <a:ext cx="694944" cy="182880"/>
+          </a:xfrm>
+          <a:prstGeom prst="rect">
+            <a:avLst/>
+          </a:prstGeom>
+          <a:noFill/>
+        </p:spPr>
+        <p:txBody>
+          <a:bodyPr wrap="square"/>
+          <a:lstStyle/>
+          <a:p>
+            <a:pPr algn="l"/>
+            <a:r>
+              <a:rPr sz="700" b="1" i="0">
+                <a:solidFill>
+                  <a:srgbClr val="16A34A"/>
+                </a:solidFill>
+                <a:latin typeface="Calibri"/>
+              </a:rPr>
+              <a:t>ON TRACK</a:t>
+            </a:r>
+          </a:p>
+        </p:txBody>
+      </p:sp>
+      <p:sp>
+        <p:nvSpPr>
+          <p:cNvPr id="18" name="TextBox 17"/>
+          <p:cNvSpPr txBox="1"/>
+          <p:nvPr/>
+        </p:nvSpPr>
+        <p:spPr>
+          <a:xfrm>
+            <a:off x="2596896" y="1591056"/>
+            <a:ext cx="694944" cy="237744"/>
+          </a:xfrm>
+          <a:prstGeom prst="rect">
+            <a:avLst/>
+          </a:prstGeom>
+          <a:noFill/>
+        </p:spPr>
+        <p:txBody>
+          <a:bodyPr wrap="square"/>
+          <a:lstStyle/>
+          <a:p>
+            <a:pPr algn="l"/>
+            <a:r>
+              <a:rPr sz="700" b="0" i="0">
+                <a:solidFill>
+                  <a:srgbClr val="8BADD0"/>
+                </a:solidFill>
+                <a:latin typeface="Calibri"/>
+              </a:rPr>
+              <a:t>Dedicated intake team</a:t>
+            </a:r>
+          </a:p>
+        </p:txBody>
+      </p:sp>
+      <p:sp>
+        <p:nvSpPr>
+          <p:cNvPr id="19" name="Rectangle 18"/>
+          <p:cNvSpPr/>
+          <p:nvPr/>
+        </p:nvSpPr>
+        <p:spPr>
+          <a:xfrm>
+            <a:off x="3401568" y="1005840"/>
+            <a:ext cx="804672" cy="164592"/>
+          </a:xfrm>
+          <a:prstGeom prst="rect">
+            <a:avLst/>
+          </a:prstGeom>
+          <a:solidFill>
+            <a:srgbClr val="16A34A"/>
+          </a:solidFill>
+          <a:ln>
+            <a:solidFill>
+              <a:srgbClr val="FFFFFF"/>
+            </a:solidFill>
+          </a:ln>
+        </p:spPr>
+        <p:style>
+          <a:lnRef idx="1">
+            <a:schemeClr val="accent1"/>
+          </a:lnRef>
+          <a:fillRef idx="3">
+            <a:schemeClr val="accent1"/>
+          </a:fillRef>
+          <a:effectRef idx="2">
+            <a:schemeClr val="accent1"/>
+          </a:effectRef>
+          <a:fontRef idx="minor">
+            <a:schemeClr val="lt1"/>
+          </a:fontRef>
+        </p:style>
+        <p:txBody>
+          <a:bodyPr rtlCol="0" anchor="ctr"/>
+          <a:lstStyle/>
+          <a:p>
+            <a:pPr algn="ctr"/>
+          </a:p>
+        </p:txBody>
+      </p:sp>
+      <p:sp>
+        <p:nvSpPr>
+          <p:cNvPr id="20" name="Rectangle 19"/>
+          <p:cNvSpPr/>
+          <p:nvPr/>
+        </p:nvSpPr>
+        <p:spPr>
+          <a:xfrm>
+            <a:off x="3401568" y="1170432"/>
+            <a:ext cx="804672" cy="676656"/>
+          </a:xfrm>
+          <a:prstGeom prst="rect">
+            <a:avLst/>
+          </a:prstGeom>
+          <a:solidFill>
+            <a:srgbClr val="162947"/>
+          </a:solidFill>
+          <a:ln>
+            <a:solidFill>
+              <a:srgbClr val="FFFFFF"/>
+            </a:solidFill>
+          </a:ln>
+        </p:spPr>
+        <p:style>
+          <a:lnRef idx="1">
+            <a:schemeClr val="accent1"/>
+          </a:lnRef>
+          <a:fillRef idx="3">
+            <a:schemeClr val="accent1"/>
+          </a:fillRef>
+          <a:effectRef idx="2">
+            <a:schemeClr val="accent1"/>
+          </a:effectRef>
+          <a:fontRef idx="minor">
+            <a:schemeClr val="lt1"/>
+          </a:fontRef>
+        </p:style>
+        <p:txBody>
+          <a:bodyPr rtlCol="0" anchor="ctr"/>
+          <a:lstStyle/>
+          <a:p>
+            <a:pPr algn="ctr"/>
+          </a:p>
+        </p:txBody>
+      </p:sp>
+      <p:sp>
+        <p:nvSpPr>
+          <p:cNvPr id="21" name="TextBox 20"/>
+          <p:cNvSpPr txBox="1"/>
+          <p:nvPr/>
+        </p:nvSpPr>
+        <p:spPr>
+          <a:xfrm>
+            <a:off x="3456432" y="1188720"/>
+            <a:ext cx="694944" cy="237744"/>
+          </a:xfrm>
+          <a:prstGeom prst="rect">
+            <a:avLst/>
+          </a:prstGeom>
+          <a:noFill/>
+        </p:spPr>
+        <p:txBody>
+          <a:bodyPr wrap="square"/>
+          <a:lstStyle/>
+          <a:p>
+            <a:pPr algn="l"/>
+            <a:r>
+              <a:rPr sz="800" b="1" i="0">
+                <a:solidFill>
+                  <a:srgbClr val="FFFFFF"/>
+                </a:solidFill>
+                <a:latin typeface="Calibri"/>
+              </a:rPr>
+              <a:t>Team</a:t>
+            </a:r>
+          </a:p>
+        </p:txBody>
+      </p:sp>
+      <p:sp>
+        <p:nvSpPr>
+          <p:cNvPr id="22" name="TextBox 21"/>
+          <p:cNvSpPr txBox="1"/>
+          <p:nvPr/>
+        </p:nvSpPr>
+        <p:spPr>
+          <a:xfrm>
+            <a:off x="3456432" y="1417320"/>
+            <a:ext cx="694944" cy="182880"/>
+          </a:xfrm>
+          <a:prstGeom prst="rect">
+            <a:avLst/>
+          </a:prstGeom>
+          <a:noFill/>
+        </p:spPr>
+        <p:txBody>
+          <a:bodyPr wrap="square"/>
+          <a:lstStyle/>
+          <a:p>
+            <a:pPr algn="l"/>
+            <a:r>
+              <a:rPr sz="700" b="1" i="0">
+                <a:solidFill>
+                  <a:srgbClr val="16A34A"/>
+                </a:solidFill>
+                <a:latin typeface="Calibri"/>
+              </a:rPr>
+              <a:t>ON TRACK</a:t>
+            </a:r>
+          </a:p>
+        </p:txBody>
+      </p:sp>
+      <p:sp>
+        <p:nvSpPr>
+          <p:cNvPr id="23" name="TextBox 22"/>
+          <p:cNvSpPr txBox="1"/>
+          <p:nvPr/>
+        </p:nvSpPr>
+        <p:spPr>
+          <a:xfrm>
+            <a:off x="3456432" y="1591056"/>
+            <a:ext cx="694944" cy="237744"/>
+          </a:xfrm>
+          <a:prstGeom prst="rect">
+            <a:avLst/>
+          </a:prstGeom>
+          <a:noFill/>
+        </p:spPr>
+        <p:txBody>
+          <a:bodyPr wrap="square"/>
+          <a:lstStyle/>
+          <a:p>
+            <a:pPr algn="l"/>
+            <a:r>
+              <a:rPr sz="700" b="0" i="0">
+                <a:solidFill>
+                  <a:srgbClr val="8BADD0"/>
+                </a:solidFill>
+                <a:latin typeface="Calibri"/>
+              </a:rPr>
+              <a:t>GM + 10-person team</a:t>
+            </a:r>
+          </a:p>
+        </p:txBody>
+      </p:sp>
+      <p:sp>
+        <p:nvSpPr>
+          <p:cNvPr id="24" name="Rectangle 23"/>
+          <p:cNvSpPr/>
+          <p:nvPr/>
+        </p:nvSpPr>
+        <p:spPr>
+          <a:xfrm>
+            <a:off x="4261104" y="1005840"/>
             <a:ext cx="804672" cy="164592"/>
           </a:xfrm>
           <a:prstGeom prst="rect">
@@ -3593,13 +3971,13 @@
       </p:sp>
       <p:sp>
         <p:nvSpPr>
-          <p:cNvPr id="15" name="Rectangle 14"/>
+          <p:cNvPr id="25" name="Rectangle 24"/>
           <p:cNvSpPr/>
           <p:nvPr/>
         </p:nvSpPr>
         <p:spPr>
           <a:xfrm>
-            <a:off x="2542032" y="1170432"/>
+            <a:off x="4261104" y="1170432"/>
             <a:ext cx="804672" cy="676656"/>
           </a:xfrm>
           <a:prstGeom prst="rect">
@@ -3638,384 +4016,6 @@
       </p:sp>
       <p:sp>
         <p:nvSpPr>
-          <p:cNvPr id="16" name="TextBox 15"/>
-          <p:cNvSpPr txBox="1"/>
-          <p:nvPr/>
-        </p:nvSpPr>
-        <p:spPr>
-          <a:xfrm>
-            <a:off x="2596896" y="1188720"/>
-            <a:ext cx="694944" cy="237744"/>
-          </a:xfrm>
-          <a:prstGeom prst="rect">
-            <a:avLst/>
-          </a:prstGeom>
-          <a:noFill/>
-        </p:spPr>
-        <p:txBody>
-          <a:bodyPr wrap="square"/>
-          <a:lstStyle/>
-          <a:p>
-            <a:pPr algn="l"/>
-            <a:r>
-              <a:rPr sz="800" b="1" i="0">
-                <a:solidFill>
-                  <a:srgbClr val="FFFFFF"/>
-                </a:solidFill>
-                <a:latin typeface="Calibri"/>
-              </a:rPr>
-              <a:t>Intake</a:t>
-            </a:r>
-          </a:p>
-        </p:txBody>
-      </p:sp>
-      <p:sp>
-        <p:nvSpPr>
-          <p:cNvPr id="17" name="TextBox 16"/>
-          <p:cNvSpPr txBox="1"/>
-          <p:nvPr/>
-        </p:nvSpPr>
-        <p:spPr>
-          <a:xfrm>
-            <a:off x="2596896" y="1417320"/>
-            <a:ext cx="694944" cy="182880"/>
-          </a:xfrm>
-          <a:prstGeom prst="rect">
-            <a:avLst/>
-          </a:prstGeom>
-          <a:noFill/>
-        </p:spPr>
-        <p:txBody>
-          <a:bodyPr wrap="square"/>
-          <a:lstStyle/>
-          <a:p>
-            <a:pPr algn="l"/>
-            <a:r>
-              <a:rPr sz="700" b="1" i="0">
-                <a:solidFill>
-                  <a:srgbClr val="D97706"/>
-                </a:solidFill>
-                <a:latin typeface="Calibri"/>
-              </a:rPr>
-              <a:t>GAPS EXIST</a:t>
-            </a:r>
-          </a:p>
-        </p:txBody>
-      </p:sp>
-      <p:sp>
-        <p:nvSpPr>
-          <p:cNvPr id="18" name="TextBox 17"/>
-          <p:cNvSpPr txBox="1"/>
-          <p:nvPr/>
-        </p:nvSpPr>
-        <p:spPr>
-          <a:xfrm>
-            <a:off x="2596896" y="1591056"/>
-            <a:ext cx="694944" cy="237744"/>
-          </a:xfrm>
-          <a:prstGeom prst="rect">
-            <a:avLst/>
-          </a:prstGeom>
-          <a:noFill/>
-        </p:spPr>
-        <p:txBody>
-          <a:bodyPr wrap="square"/>
-          <a:lstStyle/>
-          <a:p>
-            <a:pPr algn="l"/>
-            <a:r>
-              <a:rPr sz="700" b="0" i="0">
-                <a:solidFill>
-                  <a:srgbClr val="8BADD0"/>
-                </a:solidFill>
-                <a:latin typeface="Calibri"/>
-              </a:rPr>
-              <a:t>No confirmed SOP</a:t>
-            </a:r>
-          </a:p>
-        </p:txBody>
-      </p:sp>
-      <p:sp>
-        <p:nvSpPr>
-          <p:cNvPr id="19" name="Rectangle 18"/>
-          <p:cNvSpPr/>
-          <p:nvPr/>
-        </p:nvSpPr>
-        <p:spPr>
-          <a:xfrm>
-            <a:off x="3401568" y="1005840"/>
-            <a:ext cx="804672" cy="164592"/>
-          </a:xfrm>
-          <a:prstGeom prst="rect">
-            <a:avLst/>
-          </a:prstGeom>
-          <a:solidFill>
-            <a:srgbClr val="D97706"/>
-          </a:solidFill>
-          <a:ln>
-            <a:solidFill>
-              <a:srgbClr val="FFFFFF"/>
-            </a:solidFill>
-          </a:ln>
-        </p:spPr>
-        <p:style>
-          <a:lnRef idx="1">
-            <a:schemeClr val="accent1"/>
-          </a:lnRef>
-          <a:fillRef idx="3">
-            <a:schemeClr val="accent1"/>
-          </a:fillRef>
-          <a:effectRef idx="2">
-            <a:schemeClr val="accent1"/>
-          </a:effectRef>
-          <a:fontRef idx="minor">
-            <a:schemeClr val="lt1"/>
-          </a:fontRef>
-        </p:style>
-        <p:txBody>
-          <a:bodyPr rtlCol="0" anchor="ctr"/>
-          <a:lstStyle/>
-          <a:p>
-            <a:pPr algn="ctr"/>
-          </a:p>
-        </p:txBody>
-      </p:sp>
-      <p:sp>
-        <p:nvSpPr>
-          <p:cNvPr id="20" name="Rectangle 19"/>
-          <p:cNvSpPr/>
-          <p:nvPr/>
-        </p:nvSpPr>
-        <p:spPr>
-          <a:xfrm>
-            <a:off x="3401568" y="1170432"/>
-            <a:ext cx="804672" cy="676656"/>
-          </a:xfrm>
-          <a:prstGeom prst="rect">
-            <a:avLst/>
-          </a:prstGeom>
-          <a:solidFill>
-            <a:srgbClr val="162947"/>
-          </a:solidFill>
-          <a:ln>
-            <a:solidFill>
-              <a:srgbClr val="FFFFFF"/>
-            </a:solidFill>
-          </a:ln>
-        </p:spPr>
-        <p:style>
-          <a:lnRef idx="1">
-            <a:schemeClr val="accent1"/>
-          </a:lnRef>
-          <a:fillRef idx="3">
-            <a:schemeClr val="accent1"/>
-          </a:fillRef>
-          <a:effectRef idx="2">
-            <a:schemeClr val="accent1"/>
-          </a:effectRef>
-          <a:fontRef idx="minor">
-            <a:schemeClr val="lt1"/>
-          </a:fontRef>
-        </p:style>
-        <p:txBody>
-          <a:bodyPr rtlCol="0" anchor="ctr"/>
-          <a:lstStyle/>
-          <a:p>
-            <a:pPr algn="ctr"/>
-          </a:p>
-        </p:txBody>
-      </p:sp>
-      <p:sp>
-        <p:nvSpPr>
-          <p:cNvPr id="21" name="TextBox 20"/>
-          <p:cNvSpPr txBox="1"/>
-          <p:nvPr/>
-        </p:nvSpPr>
-        <p:spPr>
-          <a:xfrm>
-            <a:off x="3456432" y="1188720"/>
-            <a:ext cx="694944" cy="237744"/>
-          </a:xfrm>
-          <a:prstGeom prst="rect">
-            <a:avLst/>
-          </a:prstGeom>
-          <a:noFill/>
-        </p:spPr>
-        <p:txBody>
-          <a:bodyPr wrap="square"/>
-          <a:lstStyle/>
-          <a:p>
-            <a:pPr algn="l"/>
-            <a:r>
-              <a:rPr sz="800" b="1" i="0">
-                <a:solidFill>
-                  <a:srgbClr val="FFFFFF"/>
-                </a:solidFill>
-                <a:latin typeface="Calibri"/>
-              </a:rPr>
-              <a:t>Team</a:t>
-            </a:r>
-          </a:p>
-        </p:txBody>
-      </p:sp>
-      <p:sp>
-        <p:nvSpPr>
-          <p:cNvPr id="22" name="TextBox 21"/>
-          <p:cNvSpPr txBox="1"/>
-          <p:nvPr/>
-        </p:nvSpPr>
-        <p:spPr>
-          <a:xfrm>
-            <a:off x="3456432" y="1417320"/>
-            <a:ext cx="694944" cy="182880"/>
-          </a:xfrm>
-          <a:prstGeom prst="rect">
-            <a:avLst/>
-          </a:prstGeom>
-          <a:noFill/>
-        </p:spPr>
-        <p:txBody>
-          <a:bodyPr wrap="square"/>
-          <a:lstStyle/>
-          <a:p>
-            <a:pPr algn="l"/>
-            <a:r>
-              <a:rPr sz="700" b="1" i="0">
-                <a:solidFill>
-                  <a:srgbClr val="D97706"/>
-                </a:solidFill>
-                <a:latin typeface="Calibri"/>
-              </a:rPr>
-              <a:t>NEEDS STRUCTURE</a:t>
-            </a:r>
-          </a:p>
-        </p:txBody>
-      </p:sp>
-      <p:sp>
-        <p:nvSpPr>
-          <p:cNvPr id="23" name="TextBox 22"/>
-          <p:cNvSpPr txBox="1"/>
-          <p:nvPr/>
-        </p:nvSpPr>
-        <p:spPr>
-          <a:xfrm>
-            <a:off x="3456432" y="1591056"/>
-            <a:ext cx="694944" cy="237744"/>
-          </a:xfrm>
-          <a:prstGeom prst="rect">
-            <a:avLst/>
-          </a:prstGeom>
-          <a:noFill/>
-        </p:spPr>
-        <p:txBody>
-          <a:bodyPr wrap="square"/>
-          <a:lstStyle/>
-          <a:p>
-            <a:pPr algn="l"/>
-            <a:r>
-              <a:rPr sz="700" b="0" i="0">
-                <a:solidFill>
-                  <a:srgbClr val="8BADD0"/>
-                </a:solidFill>
-                <a:latin typeface="Calibri"/>
-              </a:rPr>
-              <a:t>GM not formalized</a:t>
-            </a:r>
-          </a:p>
-        </p:txBody>
-      </p:sp>
-      <p:sp>
-        <p:nvSpPr>
-          <p:cNvPr id="24" name="Rectangle 23"/>
-          <p:cNvSpPr/>
-          <p:nvPr/>
-        </p:nvSpPr>
-        <p:spPr>
-          <a:xfrm>
-            <a:off x="4261104" y="1005840"/>
-            <a:ext cx="804672" cy="164592"/>
-          </a:xfrm>
-          <a:prstGeom prst="rect">
-            <a:avLst/>
-          </a:prstGeom>
-          <a:solidFill>
-            <a:srgbClr val="D97706"/>
-          </a:solidFill>
-          <a:ln>
-            <a:solidFill>
-              <a:srgbClr val="FFFFFF"/>
-            </a:solidFill>
-          </a:ln>
-        </p:spPr>
-        <p:style>
-          <a:lnRef idx="1">
-            <a:schemeClr val="accent1"/>
-          </a:lnRef>
-          <a:fillRef idx="3">
-            <a:schemeClr val="accent1"/>
-          </a:fillRef>
-          <a:effectRef idx="2">
-            <a:schemeClr val="accent1"/>
-          </a:effectRef>
-          <a:fontRef idx="minor">
-            <a:schemeClr val="lt1"/>
-          </a:fontRef>
-        </p:style>
-        <p:txBody>
-          <a:bodyPr rtlCol="0" anchor="ctr"/>
-          <a:lstStyle/>
-          <a:p>
-            <a:pPr algn="ctr"/>
-          </a:p>
-        </p:txBody>
-      </p:sp>
-      <p:sp>
-        <p:nvSpPr>
-          <p:cNvPr id="25" name="Rectangle 24"/>
-          <p:cNvSpPr/>
-          <p:nvPr/>
-        </p:nvSpPr>
-        <p:spPr>
-          <a:xfrm>
-            <a:off x="4261104" y="1170432"/>
-            <a:ext cx="804672" cy="676656"/>
-          </a:xfrm>
-          <a:prstGeom prst="rect">
-            <a:avLst/>
-          </a:prstGeom>
-          <a:solidFill>
-            <a:srgbClr val="162947"/>
-          </a:solidFill>
-          <a:ln>
-            <a:solidFill>
-              <a:srgbClr val="FFFFFF"/>
-            </a:solidFill>
-          </a:ln>
-        </p:spPr>
-        <p:style>
-          <a:lnRef idx="1">
-            <a:schemeClr val="accent1"/>
-          </a:lnRef>
-          <a:fillRef idx="3">
-            <a:schemeClr val="accent1"/>
-          </a:fillRef>
-          <a:effectRef idx="2">
-            <a:schemeClr val="accent1"/>
-          </a:effectRef>
-          <a:fontRef idx="minor">
-            <a:schemeClr val="lt1"/>
-          </a:fontRef>
-        </p:style>
-        <p:txBody>
-          <a:bodyPr rtlCol="0" anchor="ctr"/>
-          <a:lstStyle/>
-          <a:p>
-            <a:pPr algn="ctr"/>
-          </a:p>
-        </p:txBody>
-      </p:sp>
-      <p:sp>
-        <p:nvSpPr>
           <p:cNvPr id="26" name="TextBox 25"/>
           <p:cNvSpPr txBox="1"/>
           <p:nvPr/>
@@ -4075,7 +4075,7 @@
                 </a:solidFill>
                 <a:latin typeface="Calibri"/>
               </a:rPr>
-              <a:t>NO VISIBILITY</a:t>
+              <a:t>IN PROGRESS</a:t>
             </a:r>
           </a:p>
         </p:txBody>
@@ -4108,7 +4108,7 @@
                 </a:solidFill>
                 <a:latin typeface="Calibri"/>
               </a:rPr>
-              <a:t>No profit tracking</a:t>
+              <a:t>No profit visibility</a:t>
             </a:r>
           </a:p>
         </p:txBody>
@@ -4453,7 +4453,7 @@
                 </a:solidFill>
                 <a:latin typeface="Calibri"/>
               </a:rPr>
-              <a:t>CoilLaw: 308 reviews at 4.8 vs. Hoyer Law's 139 — 3-pack visibility suppressed</a:t>
+              <a:t>CoilLaw: 369 reviews at 4.8 vs. Hoyer Law's 139 — gap widening every week</a:t>
             </a:r>
           </a:p>
         </p:txBody>
@@ -5110,7 +5110,7 @@
                 </a:solidFill>
                 <a:latin typeface="Calibri"/>
               </a:rPr>
-              <a:t>308 reviews</a:t>
+              <a:t>369 reviews</a:t>
             </a:r>
           </a:p>
         </p:txBody>
@@ -7021,7 +7021,7 @@
                 </a:solidFill>
                 <a:latin typeface="Calibri"/>
               </a:rPr>
-              <a:t>Fix Intake &amp;</a:t>
+              <a:t>Amplify Intake &amp;</a:t>
             </a:r>
           </a:p>
         </p:txBody>
@@ -7054,7 +7054,7 @@
                 </a:solidFill>
                 <a:latin typeface="Calibri"/>
               </a:rPr>
-              <a:t>Stop Losing Cases</a:t>
+              <a:t>Grow Conversions</a:t>
             </a:r>
           </a:p>
         </p:txBody>
@@ -7177,7 +7177,7 @@
                 </a:solidFill>
                 <a:latin typeface="Calibri"/>
               </a:rPr>
-              <a:t>Capture leads that arrive after hours and weekends</a:t>
+              <a:t>Turn paid traffic into booked consultations</a:t>
             </a:r>
           </a:p>
         </p:txBody>
@@ -7300,7 +7300,7 @@
                 </a:solidFill>
                 <a:latin typeface="Calibri"/>
               </a:rPr>
-              <a:t>Build intake SOP so every call converts consistently</a:t>
+              <a:t>AI after-hours intake — no lead left unanswered</a:t>
             </a:r>
           </a:p>
         </p:txBody>
@@ -7423,7 +7423,7 @@
                 </a:solidFill>
                 <a:latin typeface="Calibri"/>
               </a:rPr>
-              <a:t>Set a 1-hour response standard for all leads</a:t>
+              <a:t>Bilingual intake reaches all of Utah County</a:t>
             </a:r>
           </a:p>
         </p:txBody>
@@ -7546,7 +7546,7 @@
                 </a:solidFill>
                 <a:latin typeface="Calibri"/>
               </a:rPr>
-              <a:t>Train staff on a proven family law consult script</a:t>
+              <a:t>Post-case review requests after every close</a:t>
             </a:r>
           </a:p>
         </p:txBody>
@@ -7669,7 +7669,7 @@
                 </a:solidFill>
                 <a:latin typeface="Calibri"/>
               </a:rPr>
-              <a:t>Track lead-to-consult rate every month</a:t>
+              <a:t>Expand St. George paid presence — 2nd market</a:t>
             </a:r>
           </a:p>
         </p:txBody>
@@ -7780,7 +7780,7 @@
                 </a:solidFill>
                 <a:latin typeface="Calibri"/>
               </a:rPr>
-              <a:t>Install Team &amp;</a:t>
+              <a:t>Scale Team &amp;</a:t>
             </a:r>
           </a:p>
         </p:txBody>
@@ -7813,7 +7813,7 @@
                 </a:solidFill>
                 <a:latin typeface="Calibri"/>
               </a:rPr>
-              <a:t>Profit Systems</a:t>
+              <a:t>Profit Clarity</a:t>
             </a:r>
           </a:p>
         </p:txBody>
@@ -7936,7 +7936,7 @@
                 </a:solidFill>
                 <a:latin typeface="Calibri"/>
               </a:rPr>
-              <a:t>Formalize Analia's GM authority and decision rights</a:t>
+              <a:t>FCTO Level 1 — AI Skills for every staff role</a:t>
             </a:r>
           </a:p>
         </p:txBody>
@@ -8059,7 +8059,7 @@
                 </a:solidFill>
                 <a:latin typeface="Calibri"/>
               </a:rPr>
-              <a:t>Launch weekly KPI dashboard and accountability meeting</a:t>
+              <a:t>Claude Enterprise configured for Hoyer Law</a:t>
             </a:r>
           </a:p>
         </p:txBody>
@@ -8182,7 +8182,7 @@
                 </a:solidFill>
                 <a:latin typeface="Calibri"/>
               </a:rPr>
-              <a:t>Deploy AI intake response — handle leads after hours</a:t>
+              <a:t>Monthly profit dashboard by case type</a:t>
             </a:r>
           </a:p>
         </p:txBody>
@@ -8305,7 +8305,7 @@
                 </a:solidFill>
                 <a:latin typeface="Calibri"/>
               </a:rPr>
-              <a:t>Track profitability by case type — know your margins</a:t>
+              <a:t>Marketing attribution: track ROI by channel</a:t>
             </a:r>
           </a:p>
         </p:txBody>
@@ -8428,7 +8428,7 @@
                 </a:solidFill>
                 <a:latin typeface="Calibri"/>
               </a:rPr>
-              <a:t>Build monthly dashboard: revenue, costs, take-home</a:t>
+              <a:t>Growth roadmap: upgrade tiers as revenue grows</a:t>
             </a:r>
           </a:p>
         </p:txBody>
@@ -10312,7 +10312,7 @@
                 </a:solidFill>
                 <a:latin typeface="Calibri"/>
               </a:rPr>
-              <a:t>Website lead response system + intake dashboard live</a:t>
+              <a:t>Review acquisition campaign activated for CoilLaw gap</a:t>
             </a:r>
           </a:p>
         </p:txBody>
@@ -10423,7 +10423,7 @@
                 </a:solidFill>
                 <a:latin typeface="Calibri"/>
               </a:rPr>
-              <a:t>GM framework, KPI dashboard, and AI fully operational</a:t>
+              <a:t>Paid benchmarks set + AI fully deployed across team</a:t>
             </a:r>
           </a:p>
         </p:txBody>

</xml_diff>